<commit_message>
updated and correct version of project
</commit_message>
<xml_diff>
--- a/miniproject_timetable_manager/Report and PPT/SchedIQ_Presentation.pptx
+++ b/miniproject_timetable_manager/Report and PPT/SchedIQ_Presentation.pptx
@@ -18,8 +18,8 @@
     <p:sldId id="263" r:id="rId9"/>
     <p:sldId id="267" r:id="rId10"/>
     <p:sldId id="266" r:id="rId11"/>
-    <p:sldId id="264" r:id="rId12"/>
-    <p:sldId id="265" r:id="rId13"/>
+    <p:sldId id="268" r:id="rId12"/>
+    <p:sldId id="264" r:id="rId13"/>
   </p:sldIdLst>
   <p:sldSz cx="9144000" cy="5143500" type="screen16x9"/>
   <p:notesSz cx="5143500" cy="9144000"/>
@@ -490,7 +490,7 @@
     </p:spTree>
     <p:extLst>
       <p:ext uri="{BB962C8B-B14F-4D97-AF65-F5344CB8AC3E}">
-        <p14:creationId xmlns:p14="http://schemas.microsoft.com/office/powerpoint/2010/main" val="1024086991"/>
+        <p14:creationId xmlns:p14="http://schemas.microsoft.com/office/powerpoint/2010/main" val="2002672181"/>
       </p:ext>
     </p:extLst>
   </p:cSld>
@@ -574,7 +574,7 @@
     </p:spTree>
     <p:extLst>
       <p:ext uri="{BB962C8B-B14F-4D97-AF65-F5344CB8AC3E}">
-        <p14:creationId xmlns:p14="http://schemas.microsoft.com/office/powerpoint/2010/main" val="1296047678"/>
+        <p14:creationId xmlns:p14="http://schemas.microsoft.com/office/powerpoint/2010/main" val="1024086991"/>
       </p:ext>
     </p:extLst>
   </p:cSld>
@@ -1799,7 +1799,7 @@
               <a:buNone/>
             </a:pPr>
             <a:r>
-              <a:rPr lang="en-US" sz="1100" dirty="0">
+              <a:rPr lang="en-US" sz="1100" dirty="0" smtClean="0">
                 <a:solidFill>
                   <a:srgbClr val="FFFFFF"/>
                 </a:solidFill>
@@ -1807,7 +1807,7 @@
                 <a:ea typeface="Calibri" pitchFamily="34" charset="-122"/>
                 <a:cs typeface="Calibri" pitchFamily="34" charset="-120"/>
               </a:rPr>
-              <a:t>[ Your Name ]</a:t>
+              <a:t>Kamalesh S P</a:t>
             </a:r>
             <a:endParaRPr lang="en-US" sz="1100" dirty="0"/>
           </a:p>
@@ -1877,7 +1877,7 @@
               <a:buNone/>
             </a:pPr>
             <a:r>
-              <a:rPr lang="en-US" sz="1100" dirty="0">
+              <a:rPr lang="en-US" sz="1100" dirty="0" smtClean="0">
                 <a:solidFill>
                   <a:srgbClr val="FFFFFF"/>
                 </a:solidFill>
@@ -1885,7 +1885,7 @@
                 <a:ea typeface="Calibri" pitchFamily="34" charset="-122"/>
                 <a:cs typeface="Calibri" pitchFamily="34" charset="-120"/>
               </a:rPr>
-              <a:t>[ Roll Number ]</a:t>
+              <a:t>2116230701138</a:t>
             </a:r>
             <a:endParaRPr lang="en-US" sz="1100" dirty="0"/>
           </a:p>
@@ -1955,7 +1955,7 @@
               <a:buNone/>
             </a:pPr>
             <a:r>
-              <a:rPr lang="en-US" sz="1100" dirty="0">
+              <a:rPr lang="en-US" sz="1100" dirty="0" smtClean="0">
                 <a:solidFill>
                   <a:srgbClr val="FFFFFF"/>
                 </a:solidFill>
@@ -1963,7 +1963,7 @@
                 <a:ea typeface="Calibri" pitchFamily="34" charset="-122"/>
                 <a:cs typeface="Calibri" pitchFamily="34" charset="-120"/>
               </a:rPr>
-              <a:t>[ Department ]</a:t>
+              <a:t>Computer Science and Engineering</a:t>
             </a:r>
             <a:endParaRPr lang="en-US" sz="1100" dirty="0"/>
           </a:p>
@@ -2033,7 +2033,7 @@
               <a:buNone/>
             </a:pPr>
             <a:r>
-              <a:rPr lang="en-US" sz="1100" dirty="0">
+              <a:rPr lang="en-US" sz="1100" dirty="0" smtClean="0">
                 <a:solidFill>
                   <a:srgbClr val="FFFFFF"/>
                 </a:solidFill>
@@ -2041,9 +2041,8 @@
                 <a:ea typeface="Calibri" pitchFamily="34" charset="-122"/>
                 <a:cs typeface="Calibri" pitchFamily="34" charset="-120"/>
               </a:rPr>
-              <a:t>[ Subject Code ]</a:t>
-            </a:r>
-            <a:endParaRPr lang="en-US" sz="1100" dirty="0"/>
+              <a:t>CS23621</a:t>
+            </a:r>
           </a:p>
         </p:txBody>
       </p:sp>
@@ -2119,7 +2118,18 @@
                 <a:ea typeface="Calibri" pitchFamily="34" charset="-122"/>
                 <a:cs typeface="Calibri" pitchFamily="34" charset="-120"/>
               </a:rPr>
-              <a:t>Mobile Application Development Lab</a:t>
+              <a:t>Mobile Application Development </a:t>
+            </a:r>
+            <a:r>
+              <a:rPr lang="en-US" sz="1100" dirty="0" smtClean="0">
+                <a:solidFill>
+                  <a:srgbClr val="FFFFFF"/>
+                </a:solidFill>
+                <a:latin typeface="Calibri" pitchFamily="34" charset="0"/>
+                <a:ea typeface="Calibri" pitchFamily="34" charset="-122"/>
+                <a:cs typeface="Calibri" pitchFamily="34" charset="-120"/>
+              </a:rPr>
+              <a:t>Laboratory</a:t>
             </a:r>
             <a:endParaRPr lang="en-US" sz="1100" dirty="0"/>
           </a:p>
@@ -3472,6 +3482,448 @@
 
 <file path=ppt/slides/slide11.xml><?xml version="1.0" encoding="utf-8"?>
 <p:sld xmlns:a="http://schemas.openxmlformats.org/drawingml/2006/main" xmlns:r="http://schemas.openxmlformats.org/officeDocument/2006/relationships" xmlns:p="http://schemas.openxmlformats.org/presentationml/2006/main">
+  <p:cSld>
+    <p:bg>
+      <p:bgPr>
+        <a:solidFill>
+          <a:srgbClr val="FFFFFF"/>
+        </a:solidFill>
+        <a:effectLst/>
+      </p:bgPr>
+    </p:bg>
+    <p:spTree>
+      <p:nvGrpSpPr>
+        <p:cNvPr id="1" name=""/>
+        <p:cNvGrpSpPr/>
+        <p:nvPr/>
+      </p:nvGrpSpPr>
+      <p:grpSpPr>
+        <a:xfrm>
+          <a:off x="0" y="0"/>
+          <a:ext cx="0" cy="0"/>
+          <a:chOff x="0" y="0"/>
+          <a:chExt cx="0" cy="0"/>
+        </a:xfrm>
+      </p:grpSpPr>
+      <p:sp>
+        <p:nvSpPr>
+          <p:cNvPr id="2" name="Shape 0"/>
+          <p:cNvSpPr/>
+          <p:nvPr/>
+        </p:nvSpPr>
+        <p:spPr>
+          <a:xfrm>
+            <a:off x="0" y="0"/>
+            <a:ext cx="9144000" cy="566928"/>
+          </a:xfrm>
+          <a:prstGeom prst="rect">
+            <a:avLst/>
+          </a:prstGeom>
+          <a:solidFill>
+            <a:srgbClr val="1565C0"/>
+          </a:solidFill>
+          <a:ln/>
+        </p:spPr>
+      </p:sp>
+      <p:sp>
+        <p:nvSpPr>
+          <p:cNvPr id="3" name="Text 1"/>
+          <p:cNvSpPr/>
+          <p:nvPr/>
+        </p:nvSpPr>
+        <p:spPr>
+          <a:xfrm>
+            <a:off x="320040" y="0"/>
+            <a:ext cx="8503920" cy="566928"/>
+          </a:xfrm>
+          <a:prstGeom prst="rect">
+            <a:avLst/>
+          </a:prstGeom>
+          <a:noFill/>
+          <a:ln/>
+        </p:spPr>
+        <p:txBody>
+          <a:bodyPr wrap="square" lIns="0" tIns="0" rIns="0" bIns="0" rtlCol="0" anchor="ctr"/>
+          <a:lstStyle/>
+          <a:p>
+            <a:pPr marL="0" indent="0">
+              <a:buNone/>
+            </a:pPr>
+            <a:r>
+              <a:rPr lang="en-US" sz="2200" b="1" dirty="0" smtClean="0">
+                <a:solidFill>
+                  <a:srgbClr val="FFFFFF"/>
+                </a:solidFill>
+                <a:latin typeface="Calibri" pitchFamily="34" charset="0"/>
+                <a:ea typeface="Calibri" pitchFamily="34" charset="-122"/>
+                <a:cs typeface="Calibri" pitchFamily="34" charset="-120"/>
+              </a:rPr>
+              <a:t>QR Code to Download</a:t>
+            </a:r>
+            <a:r>
+              <a:rPr lang="en-US" sz="2200" b="1" dirty="0">
+                <a:solidFill>
+                  <a:srgbClr val="FFFFFF"/>
+                </a:solidFill>
+                <a:latin typeface="Calibri" pitchFamily="34" charset="0"/>
+                <a:ea typeface="Calibri" pitchFamily="34" charset="-122"/>
+                <a:cs typeface="Calibri" pitchFamily="34" charset="-120"/>
+              </a:rPr>
+              <a:t> </a:t>
+            </a:r>
+            <a:r>
+              <a:rPr lang="en-US" sz="2200" b="1" dirty="0" smtClean="0">
+                <a:solidFill>
+                  <a:srgbClr val="FFFFFF"/>
+                </a:solidFill>
+                <a:latin typeface="Calibri" pitchFamily="34" charset="0"/>
+                <a:ea typeface="Calibri" pitchFamily="34" charset="-122"/>
+                <a:cs typeface="Calibri" pitchFamily="34" charset="-120"/>
+              </a:rPr>
+              <a:t>this Application</a:t>
+            </a:r>
+            <a:endParaRPr lang="en-US" sz="2200" dirty="0"/>
+          </a:p>
+        </p:txBody>
+      </p:sp>
+      <p:sp>
+        <p:nvSpPr>
+          <p:cNvPr id="4" name="Text 2"/>
+          <p:cNvSpPr/>
+          <p:nvPr/>
+        </p:nvSpPr>
+        <p:spPr>
+          <a:xfrm>
+            <a:off x="228600" y="658368"/>
+            <a:ext cx="8686800" cy="329184"/>
+          </a:xfrm>
+          <a:prstGeom prst="rect">
+            <a:avLst/>
+          </a:prstGeom>
+          <a:noFill/>
+          <a:ln/>
+        </p:spPr>
+        <p:txBody>
+          <a:bodyPr wrap="square" lIns="25400" tIns="50800" rIns="50800" bIns="25400" rtlCol="0" anchor="ctr"/>
+          <a:lstStyle/>
+          <a:p>
+            <a:pPr marL="0" indent="0" algn="just">
+              <a:buNone/>
+            </a:pPr>
+            <a:r>
+              <a:rPr lang="en-US" sz="1150" i="1" dirty="0" smtClean="0">
+                <a:solidFill>
+                  <a:srgbClr val="475569"/>
+                </a:solidFill>
+                <a:latin typeface="Calibri" pitchFamily="34" charset="0"/>
+                <a:ea typeface="Calibri" pitchFamily="34" charset="-122"/>
+                <a:cs typeface="Calibri" pitchFamily="34" charset="-120"/>
+              </a:rPr>
+              <a:t>Scan the below QR to download this Application</a:t>
+            </a:r>
+            <a:r>
+              <a:rPr lang="en-US" sz="1150" dirty="0" smtClean="0"/>
+              <a:t>:</a:t>
+            </a:r>
+            <a:endParaRPr lang="en-US" sz="1150" i="1" dirty="0" smtClean="0">
+              <a:solidFill>
+                <a:srgbClr val="475569"/>
+              </a:solidFill>
+              <a:latin typeface="Calibri" pitchFamily="34" charset="0"/>
+              <a:ea typeface="Calibri" pitchFamily="34" charset="-122"/>
+              <a:cs typeface="Calibri" pitchFamily="34" charset="-120"/>
+            </a:endParaRPr>
+          </a:p>
+        </p:txBody>
+      </p:sp>
+      <p:sp>
+        <p:nvSpPr>
+          <p:cNvPr id="6" name="Shape 4"/>
+          <p:cNvSpPr/>
+          <p:nvPr/>
+        </p:nvSpPr>
+        <p:spPr>
+          <a:xfrm>
+            <a:off x="320040" y="1188720"/>
+            <a:ext cx="420624" cy="420624"/>
+          </a:xfrm>
+          <a:prstGeom prst="line">
+            <a:avLst/>
+          </a:prstGeom>
+          <a:solidFill>
+            <a:srgbClr val="EF4444"/>
+          </a:solidFill>
+          <a:ln/>
+        </p:spPr>
+      </p:sp>
+      <p:sp>
+        <p:nvSpPr>
+          <p:cNvPr id="7" name="Text 5"/>
+          <p:cNvSpPr/>
+          <p:nvPr/>
+        </p:nvSpPr>
+        <p:spPr>
+          <a:xfrm>
+            <a:off x="320040" y="1188720"/>
+            <a:ext cx="420624" cy="420624"/>
+          </a:xfrm>
+          <a:prstGeom prst="rect">
+            <a:avLst/>
+          </a:prstGeom>
+          <a:noFill/>
+          <a:ln/>
+        </p:spPr>
+        <p:txBody>
+          <a:bodyPr wrap="square" lIns="0" tIns="0" rIns="0" bIns="0" rtlCol="0" anchor="ctr"/>
+          <a:lstStyle/>
+          <a:p>
+            <a:pPr marL="0" indent="0" algn="ctr">
+              <a:buNone/>
+            </a:pPr>
+            <a:r>
+              <a:rPr lang="en-US" sz="1300" b="1" dirty="0">
+                <a:solidFill>
+                  <a:srgbClr val="FFFFFF"/>
+                </a:solidFill>
+                <a:latin typeface="Calibri" pitchFamily="34" charset="0"/>
+                <a:ea typeface="Calibri" pitchFamily="34" charset="-122"/>
+                <a:cs typeface="Calibri" pitchFamily="34" charset="-120"/>
+              </a:rPr>
+              <a:t>1</a:t>
+            </a:r>
+            <a:endParaRPr lang="en-US" sz="1300" dirty="0"/>
+          </a:p>
+        </p:txBody>
+      </p:sp>
+      <p:sp>
+        <p:nvSpPr>
+          <p:cNvPr id="11" name="Shape 9"/>
+          <p:cNvSpPr/>
+          <p:nvPr/>
+        </p:nvSpPr>
+        <p:spPr>
+          <a:xfrm>
+            <a:off x="320040" y="2236851"/>
+            <a:ext cx="420624" cy="420624"/>
+          </a:xfrm>
+          <a:prstGeom prst="line">
+            <a:avLst/>
+          </a:prstGeom>
+          <a:solidFill>
+            <a:srgbClr val="F59E0B"/>
+          </a:solidFill>
+          <a:ln/>
+        </p:spPr>
+      </p:sp>
+      <p:sp>
+        <p:nvSpPr>
+          <p:cNvPr id="12" name="Text 10"/>
+          <p:cNvSpPr/>
+          <p:nvPr/>
+        </p:nvSpPr>
+        <p:spPr>
+          <a:xfrm>
+            <a:off x="320040" y="2236851"/>
+            <a:ext cx="420624" cy="420624"/>
+          </a:xfrm>
+          <a:prstGeom prst="rect">
+            <a:avLst/>
+          </a:prstGeom>
+          <a:noFill/>
+          <a:ln/>
+        </p:spPr>
+        <p:txBody>
+          <a:bodyPr wrap="square" lIns="0" tIns="0" rIns="0" bIns="0" rtlCol="0" anchor="ctr"/>
+          <a:lstStyle/>
+          <a:p>
+            <a:pPr marL="0" indent="0" algn="ctr">
+              <a:buNone/>
+            </a:pPr>
+            <a:r>
+              <a:rPr lang="en-US" sz="1300" b="1" dirty="0">
+                <a:solidFill>
+                  <a:srgbClr val="FFFFFF"/>
+                </a:solidFill>
+                <a:latin typeface="Calibri" pitchFamily="34" charset="0"/>
+                <a:ea typeface="Calibri" pitchFamily="34" charset="-122"/>
+                <a:cs typeface="Calibri" pitchFamily="34" charset="-120"/>
+              </a:rPr>
+              <a:t>2</a:t>
+            </a:r>
+            <a:endParaRPr lang="en-US" sz="1300" dirty="0"/>
+          </a:p>
+        </p:txBody>
+      </p:sp>
+      <p:sp>
+        <p:nvSpPr>
+          <p:cNvPr id="16" name="Shape 14"/>
+          <p:cNvSpPr/>
+          <p:nvPr/>
+        </p:nvSpPr>
+        <p:spPr>
+          <a:xfrm>
+            <a:off x="320040" y="3284982"/>
+            <a:ext cx="420624" cy="420624"/>
+          </a:xfrm>
+          <a:prstGeom prst="line">
+            <a:avLst/>
+          </a:prstGeom>
+          <a:solidFill>
+            <a:srgbClr val="7C3AED"/>
+          </a:solidFill>
+          <a:ln/>
+        </p:spPr>
+      </p:sp>
+      <p:sp>
+        <p:nvSpPr>
+          <p:cNvPr id="17" name="Text 15"/>
+          <p:cNvSpPr/>
+          <p:nvPr/>
+        </p:nvSpPr>
+        <p:spPr>
+          <a:xfrm>
+            <a:off x="320040" y="3284982"/>
+            <a:ext cx="420624" cy="420624"/>
+          </a:xfrm>
+          <a:prstGeom prst="rect">
+            <a:avLst/>
+          </a:prstGeom>
+          <a:noFill/>
+          <a:ln/>
+        </p:spPr>
+        <p:txBody>
+          <a:bodyPr wrap="square" lIns="0" tIns="0" rIns="0" bIns="0" rtlCol="0" anchor="ctr"/>
+          <a:lstStyle/>
+          <a:p>
+            <a:pPr marL="0" indent="0" algn="ctr">
+              <a:buNone/>
+            </a:pPr>
+            <a:r>
+              <a:rPr lang="en-US" sz="1300" b="1" dirty="0">
+                <a:solidFill>
+                  <a:srgbClr val="FFFFFF"/>
+                </a:solidFill>
+                <a:latin typeface="Calibri" pitchFamily="34" charset="0"/>
+                <a:ea typeface="Calibri" pitchFamily="34" charset="-122"/>
+                <a:cs typeface="Calibri" pitchFamily="34" charset="-120"/>
+              </a:rPr>
+              <a:t>3</a:t>
+            </a:r>
+            <a:endParaRPr lang="en-US" sz="1300" dirty="0"/>
+          </a:p>
+        </p:txBody>
+      </p:sp>
+      <p:sp>
+        <p:nvSpPr>
+          <p:cNvPr id="21" name="Shape 19"/>
+          <p:cNvSpPr/>
+          <p:nvPr/>
+        </p:nvSpPr>
+        <p:spPr>
+          <a:xfrm>
+            <a:off x="320040" y="4333113"/>
+            <a:ext cx="420624" cy="420624"/>
+          </a:xfrm>
+          <a:prstGeom prst="line">
+            <a:avLst/>
+          </a:prstGeom>
+          <a:solidFill>
+            <a:srgbClr val="1565C0"/>
+          </a:solidFill>
+          <a:ln/>
+        </p:spPr>
+      </p:sp>
+      <p:sp>
+        <p:nvSpPr>
+          <p:cNvPr id="22" name="Text 20"/>
+          <p:cNvSpPr/>
+          <p:nvPr/>
+        </p:nvSpPr>
+        <p:spPr>
+          <a:xfrm>
+            <a:off x="320040" y="4333113"/>
+            <a:ext cx="420624" cy="420624"/>
+          </a:xfrm>
+          <a:prstGeom prst="rect">
+            <a:avLst/>
+          </a:prstGeom>
+          <a:noFill/>
+          <a:ln/>
+        </p:spPr>
+        <p:txBody>
+          <a:bodyPr wrap="square" lIns="0" tIns="0" rIns="0" bIns="0" rtlCol="0" anchor="ctr"/>
+          <a:lstStyle/>
+          <a:p>
+            <a:pPr marL="0" indent="0" algn="ctr">
+              <a:buNone/>
+            </a:pPr>
+            <a:r>
+              <a:rPr lang="en-US" sz="1300" b="1" dirty="0">
+                <a:solidFill>
+                  <a:srgbClr val="FFFFFF"/>
+                </a:solidFill>
+                <a:latin typeface="Calibri" pitchFamily="34" charset="0"/>
+                <a:ea typeface="Calibri" pitchFamily="34" charset="-122"/>
+                <a:cs typeface="Calibri" pitchFamily="34" charset="-120"/>
+              </a:rPr>
+              <a:t>4</a:t>
+            </a:r>
+            <a:endParaRPr lang="en-US" sz="1300" dirty="0"/>
+          </a:p>
+        </p:txBody>
+      </p:sp>
+      <p:pic>
+        <p:nvPicPr>
+          <p:cNvPr id="40" name="Picture 39"/>
+          <p:cNvPicPr>
+            <a:picLocks noChangeAspect="1"/>
+          </p:cNvPicPr>
+          <p:nvPr/>
+        </p:nvPicPr>
+        <p:blipFill>
+          <a:blip r:embed="rId3">
+            <a:extLst>
+              <a:ext uri="{28A0092B-C50C-407E-A947-70E740481C1C}">
+                <a14:useLocalDpi xmlns:a14="http://schemas.microsoft.com/office/drawing/2010/main" val="0"/>
+              </a:ext>
+            </a:extLst>
+          </a:blip>
+          <a:stretch>
+            <a:fillRect/>
+          </a:stretch>
+        </p:blipFill>
+        <p:spPr>
+          <a:xfrm>
+            <a:off x="2909608" y="1122803"/>
+            <a:ext cx="3324784" cy="3630934"/>
+          </a:xfrm>
+          <a:prstGeom prst="rect">
+            <a:avLst/>
+          </a:prstGeom>
+        </p:spPr>
+      </p:pic>
+    </p:spTree>
+    <p:extLst>
+      <p:ext uri="{BB962C8B-B14F-4D97-AF65-F5344CB8AC3E}">
+        <p14:creationId xmlns:p14="http://schemas.microsoft.com/office/powerpoint/2010/main" val="3374538666"/>
+      </p:ext>
+    </p:extLst>
+  </p:cSld>
+  <p:clrMapOvr>
+    <a:masterClrMapping/>
+  </p:clrMapOvr>
+  <p:timing>
+    <p:tnLst>
+      <p:par>
+        <p:cTn id="1" dur="indefinite" restart="never" nodeType="tmRoot"/>
+      </p:par>
+    </p:tnLst>
+  </p:timing>
+</p:sld>
+</file>
+
+<file path=ppt/slides/slide12.xml><?xml version="1.0" encoding="utf-8"?>
+<p:sld xmlns:a="http://schemas.openxmlformats.org/drawingml/2006/main" xmlns:r="http://schemas.openxmlformats.org/officeDocument/2006/relationships" xmlns:p="http://schemas.openxmlformats.org/presentationml/2006/main">
   <p:cSld name="Slide 9">
     <p:bg>
       <p:bgPr>
@@ -4767,1352 +5219,6 @@
         </p:txBody>
       </p:sp>
     </p:spTree>
-  </p:cSld>
-  <p:clrMapOvr>
-    <a:masterClrMapping/>
-  </p:clrMapOvr>
-  <p:timing>
-    <p:tnLst>
-      <p:par>
-        <p:cTn id="1" dur="indefinite" restart="never" nodeType="tmRoot"/>
-      </p:par>
-    </p:tnLst>
-  </p:timing>
-</p:sld>
-</file>
-
-<file path=ppt/slides/slide12.xml><?xml version="1.0" encoding="utf-8"?>
-<p:sld xmlns:a="http://schemas.openxmlformats.org/drawingml/2006/main" xmlns:r="http://schemas.openxmlformats.org/officeDocument/2006/relationships" xmlns:p="http://schemas.openxmlformats.org/presentationml/2006/main">
-  <p:cSld>
-    <p:bg>
-      <p:bgPr>
-        <a:solidFill>
-          <a:srgbClr val="0A1628"/>
-        </a:solidFill>
-        <a:effectLst/>
-      </p:bgPr>
-    </p:bg>
-    <p:spTree>
-      <p:nvGrpSpPr>
-        <p:cNvPr id="1" name=""/>
-        <p:cNvGrpSpPr/>
-        <p:nvPr/>
-      </p:nvGrpSpPr>
-      <p:grpSpPr>
-        <a:xfrm>
-          <a:off x="0" y="0"/>
-          <a:ext cx="0" cy="0"/>
-          <a:chOff x="0" y="0"/>
-          <a:chExt cx="0" cy="0"/>
-        </a:xfrm>
-      </p:grpSpPr>
-      <p:sp>
-        <p:nvSpPr>
-          <p:cNvPr id="2" name="Shape 0"/>
-          <p:cNvSpPr/>
-          <p:nvPr/>
-        </p:nvSpPr>
-        <p:spPr>
-          <a:xfrm>
-            <a:off x="0" y="0"/>
-            <a:ext cx="9144000" cy="566928"/>
-          </a:xfrm>
-          <a:prstGeom prst="rect">
-            <a:avLst/>
-          </a:prstGeom>
-          <a:solidFill>
-            <a:srgbClr val="0D2137"/>
-          </a:solidFill>
-          <a:ln/>
-        </p:spPr>
-      </p:sp>
-      <p:sp>
-        <p:nvSpPr>
-          <p:cNvPr id="3" name="Text 1"/>
-          <p:cNvSpPr/>
-          <p:nvPr/>
-        </p:nvSpPr>
-        <p:spPr>
-          <a:xfrm>
-            <a:off x="320040" y="0"/>
-            <a:ext cx="8503920" cy="566928"/>
-          </a:xfrm>
-          <a:prstGeom prst="rect">
-            <a:avLst/>
-          </a:prstGeom>
-          <a:noFill/>
-          <a:ln/>
-        </p:spPr>
-        <p:txBody>
-          <a:bodyPr wrap="square" lIns="0" tIns="0" rIns="0" bIns="0" rtlCol="0" anchor="ctr"/>
-          <a:lstStyle/>
-          <a:p>
-            <a:pPr marL="0" indent="0">
-              <a:buNone/>
-            </a:pPr>
-            <a:r>
-              <a:rPr lang="en-US" sz="2200" b="1" dirty="0">
-                <a:solidFill>
-                  <a:srgbClr val="FFFFFF"/>
-                </a:solidFill>
-                <a:latin typeface="Calibri" pitchFamily="34" charset="0"/>
-                <a:ea typeface="Calibri" pitchFamily="34" charset="-122"/>
-                <a:cs typeface="Calibri" pitchFamily="34" charset="-120"/>
-              </a:rPr>
-              <a:t>Project Demonstration</a:t>
-            </a:r>
-            <a:endParaRPr lang="en-US" sz="2200" dirty="0"/>
-          </a:p>
-        </p:txBody>
-      </p:sp>
-      <p:sp>
-        <p:nvSpPr>
-          <p:cNvPr id="4" name="Text 2"/>
-          <p:cNvSpPr/>
-          <p:nvPr/>
-        </p:nvSpPr>
-        <p:spPr>
-          <a:xfrm>
-            <a:off x="228600" y="658368"/>
-            <a:ext cx="8686800" cy="347472"/>
-          </a:xfrm>
-          <a:prstGeom prst="rect">
-            <a:avLst/>
-          </a:prstGeom>
-          <a:noFill/>
-          <a:ln/>
-        </p:spPr>
-        <p:txBody>
-          <a:bodyPr wrap="square" lIns="25400" tIns="50800" rIns="50800" bIns="25400" rtlCol="0" anchor="ctr"/>
-          <a:lstStyle/>
-          <a:p>
-            <a:pPr marL="0" indent="0" algn="just">
-              <a:buNone/>
-            </a:pPr>
-            <a:r>
-              <a:rPr lang="en-US" sz="1150" i="1" dirty="0">
-                <a:solidFill>
-                  <a:srgbClr val="90CAF9"/>
-                </a:solidFill>
-                <a:latin typeface="Calibri" pitchFamily="34" charset="0"/>
-                <a:ea typeface="Calibri" pitchFamily="34" charset="-122"/>
-                <a:cs typeface="Calibri" pitchFamily="34" charset="-120"/>
-              </a:rPr>
-              <a:t>The following walkthrough describes the complete user journey through SchedIQ from first launch to semester-end reset.</a:t>
-            </a:r>
-            <a:endParaRPr lang="en-US" sz="1150" dirty="0"/>
-          </a:p>
-        </p:txBody>
-      </p:sp>
-      <p:sp>
-        <p:nvSpPr>
-          <p:cNvPr id="5" name="Shape 3"/>
-          <p:cNvSpPr/>
-          <p:nvPr/>
-        </p:nvSpPr>
-        <p:spPr>
-          <a:xfrm>
-            <a:off x="228600" y="1042416"/>
-            <a:ext cx="4251960" cy="877824"/>
-          </a:xfrm>
-          <a:prstGeom prst="rect">
-            <a:avLst/>
-          </a:prstGeom>
-          <a:solidFill>
-            <a:srgbClr val="0D2137"/>
-          </a:solidFill>
-          <a:ln w="12700">
-            <a:solidFill>
-              <a:srgbClr val="1E3A5F"/>
-            </a:solidFill>
-            <a:prstDash val="solid"/>
-          </a:ln>
-        </p:spPr>
-      </p:sp>
-      <p:sp>
-        <p:nvSpPr>
-          <p:cNvPr id="6" name="Shape 4"/>
-          <p:cNvSpPr/>
-          <p:nvPr/>
-        </p:nvSpPr>
-        <p:spPr>
-          <a:xfrm>
-            <a:off x="320040" y="1225296"/>
-            <a:ext cx="457200" cy="457200"/>
-          </a:xfrm>
-          <a:prstGeom prst="line">
-            <a:avLst/>
-          </a:prstGeom>
-          <a:solidFill>
-            <a:srgbClr val="00B4D8"/>
-          </a:solidFill>
-          <a:ln/>
-        </p:spPr>
-      </p:sp>
-      <p:sp>
-        <p:nvSpPr>
-          <p:cNvPr id="7" name="Text 5"/>
-          <p:cNvSpPr/>
-          <p:nvPr/>
-        </p:nvSpPr>
-        <p:spPr>
-          <a:xfrm>
-            <a:off x="320040" y="1225296"/>
-            <a:ext cx="457200" cy="457200"/>
-          </a:xfrm>
-          <a:prstGeom prst="rect">
-            <a:avLst/>
-          </a:prstGeom>
-          <a:noFill/>
-          <a:ln/>
-        </p:spPr>
-        <p:txBody>
-          <a:bodyPr wrap="square" lIns="0" tIns="0" rIns="0" bIns="0" rtlCol="0" anchor="ctr"/>
-          <a:lstStyle/>
-          <a:p>
-            <a:pPr marL="0" indent="0" algn="ctr">
-              <a:buNone/>
-            </a:pPr>
-            <a:r>
-              <a:rPr lang="en-US" sz="1400" b="1" dirty="0">
-                <a:solidFill>
-                  <a:srgbClr val="0A1628"/>
-                </a:solidFill>
-                <a:latin typeface="Calibri" pitchFamily="34" charset="0"/>
-                <a:ea typeface="Calibri" pitchFamily="34" charset="-122"/>
-                <a:cs typeface="Calibri" pitchFamily="34" charset="-120"/>
-              </a:rPr>
-              <a:t>1</a:t>
-            </a:r>
-            <a:endParaRPr lang="en-US" sz="1400" dirty="0"/>
-          </a:p>
-        </p:txBody>
-      </p:sp>
-      <p:sp>
-        <p:nvSpPr>
-          <p:cNvPr id="8" name="Text 6"/>
-          <p:cNvSpPr/>
-          <p:nvPr/>
-        </p:nvSpPr>
-        <p:spPr>
-          <a:xfrm>
-            <a:off x="868680" y="1097280"/>
-            <a:ext cx="3520440" cy="274320"/>
-          </a:xfrm>
-          <a:prstGeom prst="rect">
-            <a:avLst/>
-          </a:prstGeom>
-          <a:noFill/>
-          <a:ln/>
-        </p:spPr>
-        <p:txBody>
-          <a:bodyPr wrap="square" lIns="0" tIns="0" rIns="0" bIns="0" rtlCol="0" anchor="ctr"/>
-          <a:lstStyle/>
-          <a:p>
-            <a:pPr marL="0" indent="0">
-              <a:buNone/>
-            </a:pPr>
-            <a:r>
-              <a:rPr lang="en-US" sz="1050" b="1" dirty="0">
-                <a:solidFill>
-                  <a:srgbClr val="00B4D8"/>
-                </a:solidFill>
-                <a:latin typeface="Calibri" pitchFamily="34" charset="0"/>
-                <a:ea typeface="Calibri" pitchFamily="34" charset="-122"/>
-                <a:cs typeface="Calibri" pitchFamily="34" charset="-120"/>
-              </a:rPr>
-              <a:t>Step 1 — Launch &amp; Onboarding</a:t>
-            </a:r>
-            <a:endParaRPr lang="en-US" sz="1050" dirty="0"/>
-          </a:p>
-        </p:txBody>
-      </p:sp>
-      <p:sp>
-        <p:nvSpPr>
-          <p:cNvPr id="9" name="Text 7"/>
-          <p:cNvSpPr/>
-          <p:nvPr/>
-        </p:nvSpPr>
-        <p:spPr>
-          <a:xfrm>
-            <a:off x="868680" y="1371600"/>
-            <a:ext cx="3520440" cy="512064"/>
-          </a:xfrm>
-          <a:prstGeom prst="rect">
-            <a:avLst/>
-          </a:prstGeom>
-          <a:noFill/>
-          <a:ln/>
-        </p:spPr>
-        <p:txBody>
-          <a:bodyPr wrap="square" lIns="12700" tIns="38100" rIns="38100" bIns="12700" rtlCol="0" anchor="ctr"/>
-          <a:lstStyle/>
-          <a:p>
-            <a:pPr marL="0" indent="0" algn="just">
-              <a:buNone/>
-            </a:pPr>
-            <a:r>
-              <a:rPr lang="en-US" sz="880" dirty="0">
-                <a:solidFill>
-                  <a:srgbClr val="CBD5E1"/>
-                </a:solidFill>
-                <a:latin typeface="Calibri" pitchFamily="34" charset="0"/>
-                <a:ea typeface="Calibri" pitchFamily="34" charset="-122"/>
-                <a:cs typeface="Calibri" pitchFamily="34" charset="-120"/>
-              </a:rPr>
-              <a:t>On first launch, a sleek onboarding screen guides the student through the app's capabilities. It appears once only. Tapping Get Started initialises all six data providers and loads the main shell.</a:t>
-            </a:r>
-            <a:endParaRPr lang="en-US" sz="880" dirty="0"/>
-          </a:p>
-        </p:txBody>
-      </p:sp>
-      <p:sp>
-        <p:nvSpPr>
-          <p:cNvPr id="10" name="Shape 8"/>
-          <p:cNvSpPr/>
-          <p:nvPr/>
-        </p:nvSpPr>
-        <p:spPr>
-          <a:xfrm>
-            <a:off x="228600" y="2048256"/>
-            <a:ext cx="4251960" cy="877824"/>
-          </a:xfrm>
-          <a:prstGeom prst="rect">
-            <a:avLst/>
-          </a:prstGeom>
-          <a:solidFill>
-            <a:srgbClr val="0D2137"/>
-          </a:solidFill>
-          <a:ln w="12700">
-            <a:solidFill>
-              <a:srgbClr val="1E3A5F"/>
-            </a:solidFill>
-            <a:prstDash val="solid"/>
-          </a:ln>
-        </p:spPr>
-      </p:sp>
-      <p:sp>
-        <p:nvSpPr>
-          <p:cNvPr id="11" name="Shape 9"/>
-          <p:cNvSpPr/>
-          <p:nvPr/>
-        </p:nvSpPr>
-        <p:spPr>
-          <a:xfrm>
-            <a:off x="320040" y="2231136"/>
-            <a:ext cx="457200" cy="457200"/>
-          </a:xfrm>
-          <a:prstGeom prst="line">
-            <a:avLst/>
-          </a:prstGeom>
-          <a:solidFill>
-            <a:srgbClr val="10B981"/>
-          </a:solidFill>
-          <a:ln/>
-        </p:spPr>
-      </p:sp>
-      <p:sp>
-        <p:nvSpPr>
-          <p:cNvPr id="12" name="Text 10"/>
-          <p:cNvSpPr/>
-          <p:nvPr/>
-        </p:nvSpPr>
-        <p:spPr>
-          <a:xfrm>
-            <a:off x="320040" y="2231136"/>
-            <a:ext cx="457200" cy="457200"/>
-          </a:xfrm>
-          <a:prstGeom prst="rect">
-            <a:avLst/>
-          </a:prstGeom>
-          <a:noFill/>
-          <a:ln/>
-        </p:spPr>
-        <p:txBody>
-          <a:bodyPr wrap="square" lIns="0" tIns="0" rIns="0" bIns="0" rtlCol="0" anchor="ctr"/>
-          <a:lstStyle/>
-          <a:p>
-            <a:pPr marL="0" indent="0" algn="ctr">
-              <a:buNone/>
-            </a:pPr>
-            <a:r>
-              <a:rPr lang="en-US" sz="1400" b="1" dirty="0">
-                <a:solidFill>
-                  <a:srgbClr val="0A1628"/>
-                </a:solidFill>
-                <a:latin typeface="Calibri" pitchFamily="34" charset="0"/>
-                <a:ea typeface="Calibri" pitchFamily="34" charset="-122"/>
-                <a:cs typeface="Calibri" pitchFamily="34" charset="-120"/>
-              </a:rPr>
-              <a:t>2</a:t>
-            </a:r>
-            <a:endParaRPr lang="en-US" sz="1400" dirty="0"/>
-          </a:p>
-        </p:txBody>
-      </p:sp>
-      <p:sp>
-        <p:nvSpPr>
-          <p:cNvPr id="13" name="Text 11"/>
-          <p:cNvSpPr/>
-          <p:nvPr/>
-        </p:nvSpPr>
-        <p:spPr>
-          <a:xfrm>
-            <a:off x="868680" y="2103120"/>
-            <a:ext cx="3520440" cy="274320"/>
-          </a:xfrm>
-          <a:prstGeom prst="rect">
-            <a:avLst/>
-          </a:prstGeom>
-          <a:noFill/>
-          <a:ln/>
-        </p:spPr>
-        <p:txBody>
-          <a:bodyPr wrap="square" lIns="0" tIns="0" rIns="0" bIns="0" rtlCol="0" anchor="ctr"/>
-          <a:lstStyle/>
-          <a:p>
-            <a:pPr marL="0" indent="0">
-              <a:buNone/>
-            </a:pPr>
-            <a:r>
-              <a:rPr lang="en-US" sz="1050" b="1" dirty="0">
-                <a:solidFill>
-                  <a:srgbClr val="10B981"/>
-                </a:solidFill>
-                <a:latin typeface="Calibri" pitchFamily="34" charset="0"/>
-                <a:ea typeface="Calibri" pitchFamily="34" charset="-122"/>
-                <a:cs typeface="Calibri" pitchFamily="34" charset="-120"/>
-              </a:rPr>
-              <a:t>Step 2 — Dashboard / Home Screen</a:t>
-            </a:r>
-            <a:endParaRPr lang="en-US" sz="1050" dirty="0"/>
-          </a:p>
-        </p:txBody>
-      </p:sp>
-      <p:sp>
-        <p:nvSpPr>
-          <p:cNvPr id="14" name="Text 12"/>
-          <p:cNvSpPr/>
-          <p:nvPr/>
-        </p:nvSpPr>
-        <p:spPr>
-          <a:xfrm>
-            <a:off x="868680" y="2377440"/>
-            <a:ext cx="3520440" cy="512064"/>
-          </a:xfrm>
-          <a:prstGeom prst="rect">
-            <a:avLst/>
-          </a:prstGeom>
-          <a:noFill/>
-          <a:ln/>
-        </p:spPr>
-        <p:txBody>
-          <a:bodyPr wrap="square" lIns="12700" tIns="38100" rIns="38100" bIns="12700" rtlCol="0" anchor="ctr"/>
-          <a:lstStyle/>
-          <a:p>
-            <a:pPr marL="0" indent="0" algn="just">
-              <a:buNone/>
-            </a:pPr>
-            <a:r>
-              <a:rPr lang="en-US" sz="880" dirty="0">
-                <a:solidFill>
-                  <a:srgbClr val="CBD5E1"/>
-                </a:solidFill>
-                <a:latin typeface="Calibri" pitchFamily="34" charset="0"/>
-                <a:ea typeface="Calibri" pitchFamily="34" charset="-122"/>
-                <a:cs typeface="Calibri" pitchFamily="34" charset="-120"/>
-              </a:rPr>
-              <a:t>The home screen automatically displays the timetable for the current day. A tab bar lists abbreviated day names with a dot indicator on today's tab. If no classes have been added, a friendly empty-state prompt is shown with instructions.</a:t>
-            </a:r>
-            <a:endParaRPr lang="en-US" sz="880" dirty="0"/>
-          </a:p>
-        </p:txBody>
-      </p:sp>
-      <p:sp>
-        <p:nvSpPr>
-          <p:cNvPr id="15" name="Shape 13"/>
-          <p:cNvSpPr/>
-          <p:nvPr/>
-        </p:nvSpPr>
-        <p:spPr>
-          <a:xfrm>
-            <a:off x="228600" y="3054096"/>
-            <a:ext cx="4251960" cy="877824"/>
-          </a:xfrm>
-          <a:prstGeom prst="rect">
-            <a:avLst/>
-          </a:prstGeom>
-          <a:solidFill>
-            <a:srgbClr val="0D2137"/>
-          </a:solidFill>
-          <a:ln w="12700">
-            <a:solidFill>
-              <a:srgbClr val="1E3A5F"/>
-            </a:solidFill>
-            <a:prstDash val="solid"/>
-          </a:ln>
-        </p:spPr>
-      </p:sp>
-      <p:sp>
-        <p:nvSpPr>
-          <p:cNvPr id="16" name="Shape 14"/>
-          <p:cNvSpPr/>
-          <p:nvPr/>
-        </p:nvSpPr>
-        <p:spPr>
-          <a:xfrm>
-            <a:off x="320040" y="3236976"/>
-            <a:ext cx="457200" cy="457200"/>
-          </a:xfrm>
-          <a:prstGeom prst="line">
-            <a:avLst/>
-          </a:prstGeom>
-          <a:solidFill>
-            <a:srgbClr val="F59E0B"/>
-          </a:solidFill>
-          <a:ln/>
-        </p:spPr>
-      </p:sp>
-      <p:sp>
-        <p:nvSpPr>
-          <p:cNvPr id="17" name="Text 15"/>
-          <p:cNvSpPr/>
-          <p:nvPr/>
-        </p:nvSpPr>
-        <p:spPr>
-          <a:xfrm>
-            <a:off x="320040" y="3236976"/>
-            <a:ext cx="457200" cy="457200"/>
-          </a:xfrm>
-          <a:prstGeom prst="rect">
-            <a:avLst/>
-          </a:prstGeom>
-          <a:noFill/>
-          <a:ln/>
-        </p:spPr>
-        <p:txBody>
-          <a:bodyPr wrap="square" lIns="0" tIns="0" rIns="0" bIns="0" rtlCol="0" anchor="ctr"/>
-          <a:lstStyle/>
-          <a:p>
-            <a:pPr marL="0" indent="0" algn="ctr">
-              <a:buNone/>
-            </a:pPr>
-            <a:r>
-              <a:rPr lang="en-US" sz="1400" b="1" dirty="0">
-                <a:solidFill>
-                  <a:srgbClr val="0A1628"/>
-                </a:solidFill>
-                <a:latin typeface="Calibri" pitchFamily="34" charset="0"/>
-                <a:ea typeface="Calibri" pitchFamily="34" charset="-122"/>
-                <a:cs typeface="Calibri" pitchFamily="34" charset="-120"/>
-              </a:rPr>
-              <a:t>3</a:t>
-            </a:r>
-            <a:endParaRPr lang="en-US" sz="1400" dirty="0"/>
-          </a:p>
-        </p:txBody>
-      </p:sp>
-      <p:sp>
-        <p:nvSpPr>
-          <p:cNvPr id="18" name="Text 16"/>
-          <p:cNvSpPr/>
-          <p:nvPr/>
-        </p:nvSpPr>
-        <p:spPr>
-          <a:xfrm>
-            <a:off x="868680" y="3108960"/>
-            <a:ext cx="3520440" cy="274320"/>
-          </a:xfrm>
-          <a:prstGeom prst="rect">
-            <a:avLst/>
-          </a:prstGeom>
-          <a:noFill/>
-          <a:ln/>
-        </p:spPr>
-        <p:txBody>
-          <a:bodyPr wrap="square" lIns="0" tIns="0" rIns="0" bIns="0" rtlCol="0" anchor="ctr"/>
-          <a:lstStyle/>
-          <a:p>
-            <a:pPr marL="0" indent="0">
-              <a:buNone/>
-            </a:pPr>
-            <a:r>
-              <a:rPr lang="en-US" sz="1050" b="1" dirty="0">
-                <a:solidFill>
-                  <a:srgbClr val="F59E0B"/>
-                </a:solidFill>
-                <a:latin typeface="Calibri" pitchFamily="34" charset="0"/>
-                <a:ea typeface="Calibri" pitchFamily="34" charset="-122"/>
-                <a:cs typeface="Calibri" pitchFamily="34" charset="-120"/>
-              </a:rPr>
-              <a:t>Step 3 — Adding a New Class</a:t>
-            </a:r>
-            <a:endParaRPr lang="en-US" sz="1050" dirty="0"/>
-          </a:p>
-        </p:txBody>
-      </p:sp>
-      <p:sp>
-        <p:nvSpPr>
-          <p:cNvPr id="19" name="Text 17"/>
-          <p:cNvSpPr/>
-          <p:nvPr/>
-        </p:nvSpPr>
-        <p:spPr>
-          <a:xfrm>
-            <a:off x="868680" y="3383280"/>
-            <a:ext cx="3520440" cy="512064"/>
-          </a:xfrm>
-          <a:prstGeom prst="rect">
-            <a:avLst/>
-          </a:prstGeom>
-          <a:noFill/>
-          <a:ln/>
-        </p:spPr>
-        <p:txBody>
-          <a:bodyPr wrap="square" lIns="12700" tIns="38100" rIns="38100" bIns="12700" rtlCol="0" anchor="ctr"/>
-          <a:lstStyle/>
-          <a:p>
-            <a:pPr marL="0" indent="0" algn="just">
-              <a:buNone/>
-            </a:pPr>
-            <a:r>
-              <a:rPr lang="en-US" sz="880" dirty="0">
-                <a:solidFill>
-                  <a:srgbClr val="CBD5E1"/>
-                </a:solidFill>
-                <a:latin typeface="Calibri" pitchFamily="34" charset="0"/>
-                <a:ea typeface="Calibri" pitchFamily="34" charset="-122"/>
-                <a:cs typeface="Calibri" pitchFamily="34" charset="-120"/>
-              </a:rPr>
-              <a:t>The student taps Add Class and fills in the subject, day, start time, end time, and room. On Save, the overlap engine queries the database. If the slot is free the entry is saved; if a conflict is detected, the form shows an error and the entry is not saved.</a:t>
-            </a:r>
-            <a:endParaRPr lang="en-US" sz="880" dirty="0"/>
-          </a:p>
-        </p:txBody>
-      </p:sp>
-      <p:sp>
-        <p:nvSpPr>
-          <p:cNvPr id="20" name="Shape 18"/>
-          <p:cNvSpPr/>
-          <p:nvPr/>
-        </p:nvSpPr>
-        <p:spPr>
-          <a:xfrm>
-            <a:off x="228600" y="4059936"/>
-            <a:ext cx="4251960" cy="877824"/>
-          </a:xfrm>
-          <a:prstGeom prst="rect">
-            <a:avLst/>
-          </a:prstGeom>
-          <a:solidFill>
-            <a:srgbClr val="0D2137"/>
-          </a:solidFill>
-          <a:ln w="12700">
-            <a:solidFill>
-              <a:srgbClr val="1E3A5F"/>
-            </a:solidFill>
-            <a:prstDash val="solid"/>
-          </a:ln>
-        </p:spPr>
-      </p:sp>
-      <p:sp>
-        <p:nvSpPr>
-          <p:cNvPr id="21" name="Shape 19"/>
-          <p:cNvSpPr/>
-          <p:nvPr/>
-        </p:nvSpPr>
-        <p:spPr>
-          <a:xfrm>
-            <a:off x="320040" y="4242816"/>
-            <a:ext cx="457200" cy="457200"/>
-          </a:xfrm>
-          <a:prstGeom prst="line">
-            <a:avLst/>
-          </a:prstGeom>
-          <a:solidFill>
-            <a:srgbClr val="EF4444"/>
-          </a:solidFill>
-          <a:ln/>
-        </p:spPr>
-      </p:sp>
-      <p:sp>
-        <p:nvSpPr>
-          <p:cNvPr id="22" name="Text 20"/>
-          <p:cNvSpPr/>
-          <p:nvPr/>
-        </p:nvSpPr>
-        <p:spPr>
-          <a:xfrm>
-            <a:off x="320040" y="4242816"/>
-            <a:ext cx="457200" cy="457200"/>
-          </a:xfrm>
-          <a:prstGeom prst="rect">
-            <a:avLst/>
-          </a:prstGeom>
-          <a:noFill/>
-          <a:ln/>
-        </p:spPr>
-        <p:txBody>
-          <a:bodyPr wrap="square" lIns="0" tIns="0" rIns="0" bIns="0" rtlCol="0" anchor="ctr"/>
-          <a:lstStyle/>
-          <a:p>
-            <a:pPr marL="0" indent="0" algn="ctr">
-              <a:buNone/>
-            </a:pPr>
-            <a:r>
-              <a:rPr lang="en-US" sz="1400" b="1" dirty="0">
-                <a:solidFill>
-                  <a:srgbClr val="0A1628"/>
-                </a:solidFill>
-                <a:latin typeface="Calibri" pitchFamily="34" charset="0"/>
-                <a:ea typeface="Calibri" pitchFamily="34" charset="-122"/>
-                <a:cs typeface="Calibri" pitchFamily="34" charset="-120"/>
-              </a:rPr>
-              <a:t>4</a:t>
-            </a:r>
-            <a:endParaRPr lang="en-US" sz="1400" dirty="0"/>
-          </a:p>
-        </p:txBody>
-      </p:sp>
-      <p:sp>
-        <p:nvSpPr>
-          <p:cNvPr id="23" name="Text 21"/>
-          <p:cNvSpPr/>
-          <p:nvPr/>
-        </p:nvSpPr>
-        <p:spPr>
-          <a:xfrm>
-            <a:off x="868680" y="4114800"/>
-            <a:ext cx="3520440" cy="274320"/>
-          </a:xfrm>
-          <a:prstGeom prst="rect">
-            <a:avLst/>
-          </a:prstGeom>
-          <a:noFill/>
-          <a:ln/>
-        </p:spPr>
-        <p:txBody>
-          <a:bodyPr wrap="square" lIns="0" tIns="0" rIns="0" bIns="0" rtlCol="0" anchor="ctr"/>
-          <a:lstStyle/>
-          <a:p>
-            <a:pPr marL="0" indent="0">
-              <a:buNone/>
-            </a:pPr>
-            <a:r>
-              <a:rPr lang="en-US" sz="1050" b="1" dirty="0">
-                <a:solidFill>
-                  <a:srgbClr val="EF4444"/>
-                </a:solidFill>
-                <a:latin typeface="Calibri" pitchFamily="34" charset="0"/>
-                <a:ea typeface="Calibri" pitchFamily="34" charset="-122"/>
-                <a:cs typeface="Calibri" pitchFamily="34" charset="-120"/>
-              </a:rPr>
-              <a:t>Step 4 — Marking Attendance</a:t>
-            </a:r>
-            <a:endParaRPr lang="en-US" sz="1050" dirty="0"/>
-          </a:p>
-        </p:txBody>
-      </p:sp>
-      <p:sp>
-        <p:nvSpPr>
-          <p:cNvPr id="24" name="Text 22"/>
-          <p:cNvSpPr/>
-          <p:nvPr/>
-        </p:nvSpPr>
-        <p:spPr>
-          <a:xfrm>
-            <a:off x="868680" y="4389120"/>
-            <a:ext cx="3520440" cy="512064"/>
-          </a:xfrm>
-          <a:prstGeom prst="rect">
-            <a:avLst/>
-          </a:prstGeom>
-          <a:noFill/>
-          <a:ln/>
-        </p:spPr>
-        <p:txBody>
-          <a:bodyPr wrap="square" lIns="12700" tIns="38100" rIns="38100" bIns="12700" rtlCol="0" anchor="ctr"/>
-          <a:lstStyle/>
-          <a:p>
-            <a:pPr marL="0" indent="0" algn="just">
-              <a:buNone/>
-            </a:pPr>
-            <a:r>
-              <a:rPr lang="en-US" sz="880" dirty="0">
-                <a:solidFill>
-                  <a:srgbClr val="CBD5E1"/>
-                </a:solidFill>
-                <a:latin typeface="Calibri" pitchFamily="34" charset="0"/>
-                <a:ea typeface="Calibri" pitchFamily="34" charset="-122"/>
-                <a:cs typeface="Calibri" pitchFamily="34" charset="-120"/>
-              </a:rPr>
-              <a:t>After each class, the student marks Present or Absent. The Attendance screen immediately recalculates the running percentage per subject. If it drops below the Warning threshold a yellow alert appears; below Danger a red alert is shown.</a:t>
-            </a:r>
-            <a:endParaRPr lang="en-US" sz="880" dirty="0"/>
-          </a:p>
-        </p:txBody>
-      </p:sp>
-      <p:sp>
-        <p:nvSpPr>
-          <p:cNvPr id="25" name="Shape 23"/>
-          <p:cNvSpPr/>
-          <p:nvPr/>
-        </p:nvSpPr>
-        <p:spPr>
-          <a:xfrm>
-            <a:off x="4709160" y="2048256"/>
-            <a:ext cx="4251960" cy="877824"/>
-          </a:xfrm>
-          <a:prstGeom prst="rect">
-            <a:avLst/>
-          </a:prstGeom>
-          <a:solidFill>
-            <a:srgbClr val="0D2137"/>
-          </a:solidFill>
-          <a:ln w="12700">
-            <a:solidFill>
-              <a:srgbClr val="1E3A5F"/>
-            </a:solidFill>
-            <a:prstDash val="solid"/>
-          </a:ln>
-        </p:spPr>
-      </p:sp>
-      <p:sp>
-        <p:nvSpPr>
-          <p:cNvPr id="26" name="Shape 24"/>
-          <p:cNvSpPr/>
-          <p:nvPr/>
-        </p:nvSpPr>
-        <p:spPr>
-          <a:xfrm>
-            <a:off x="4800600" y="2231136"/>
-            <a:ext cx="457200" cy="457200"/>
-          </a:xfrm>
-          <a:prstGeom prst="line">
-            <a:avLst/>
-          </a:prstGeom>
-          <a:solidFill>
-            <a:srgbClr val="7C3AED"/>
-          </a:solidFill>
-          <a:ln/>
-        </p:spPr>
-      </p:sp>
-      <p:sp>
-        <p:nvSpPr>
-          <p:cNvPr id="27" name="Text 25"/>
-          <p:cNvSpPr/>
-          <p:nvPr/>
-        </p:nvSpPr>
-        <p:spPr>
-          <a:xfrm>
-            <a:off x="4800600" y="2231136"/>
-            <a:ext cx="457200" cy="457200"/>
-          </a:xfrm>
-          <a:prstGeom prst="rect">
-            <a:avLst/>
-          </a:prstGeom>
-          <a:noFill/>
-          <a:ln/>
-        </p:spPr>
-        <p:txBody>
-          <a:bodyPr wrap="square" lIns="0" tIns="0" rIns="0" bIns="0" rtlCol="0" anchor="ctr"/>
-          <a:lstStyle/>
-          <a:p>
-            <a:pPr marL="0" indent="0" algn="ctr">
-              <a:buNone/>
-            </a:pPr>
-            <a:r>
-              <a:rPr lang="en-US" sz="1400" b="1" dirty="0">
-                <a:solidFill>
-                  <a:srgbClr val="0A1628"/>
-                </a:solidFill>
-                <a:latin typeface="Calibri" pitchFamily="34" charset="0"/>
-                <a:ea typeface="Calibri" pitchFamily="34" charset="-122"/>
-                <a:cs typeface="Calibri" pitchFamily="34" charset="-120"/>
-              </a:rPr>
-              <a:t>5</a:t>
-            </a:r>
-            <a:endParaRPr lang="en-US" sz="1400" dirty="0"/>
-          </a:p>
-        </p:txBody>
-      </p:sp>
-      <p:sp>
-        <p:nvSpPr>
-          <p:cNvPr id="28" name="Text 26"/>
-          <p:cNvSpPr/>
-          <p:nvPr/>
-        </p:nvSpPr>
-        <p:spPr>
-          <a:xfrm>
-            <a:off x="5349240" y="2103120"/>
-            <a:ext cx="3520440" cy="274320"/>
-          </a:xfrm>
-          <a:prstGeom prst="rect">
-            <a:avLst/>
-          </a:prstGeom>
-          <a:noFill/>
-          <a:ln/>
-        </p:spPr>
-        <p:txBody>
-          <a:bodyPr wrap="square" lIns="0" tIns="0" rIns="0" bIns="0" rtlCol="0" anchor="ctr"/>
-          <a:lstStyle/>
-          <a:p>
-            <a:pPr marL="0" indent="0">
-              <a:buNone/>
-            </a:pPr>
-            <a:r>
-              <a:rPr lang="en-US" sz="1050" b="1" dirty="0">
-                <a:solidFill>
-                  <a:srgbClr val="7C3AED"/>
-                </a:solidFill>
-                <a:latin typeface="Calibri" pitchFamily="34" charset="0"/>
-                <a:ea typeface="Calibri" pitchFamily="34" charset="-122"/>
-                <a:cs typeface="Calibri" pitchFamily="34" charset="-120"/>
-              </a:rPr>
-              <a:t>Step 5 — Exporting the Timetable as PDF</a:t>
-            </a:r>
-            <a:endParaRPr lang="en-US" sz="1050" dirty="0"/>
-          </a:p>
-        </p:txBody>
-      </p:sp>
-      <p:sp>
-        <p:nvSpPr>
-          <p:cNvPr id="29" name="Text 27"/>
-          <p:cNvSpPr/>
-          <p:nvPr/>
-        </p:nvSpPr>
-        <p:spPr>
-          <a:xfrm>
-            <a:off x="5349240" y="2377440"/>
-            <a:ext cx="3520440" cy="512064"/>
-          </a:xfrm>
-          <a:prstGeom prst="rect">
-            <a:avLst/>
-          </a:prstGeom>
-          <a:noFill/>
-          <a:ln/>
-        </p:spPr>
-        <p:txBody>
-          <a:bodyPr wrap="square" lIns="12700" tIns="38100" rIns="38100" bIns="12700" rtlCol="0" anchor="ctr"/>
-          <a:lstStyle/>
-          <a:p>
-            <a:pPr marL="0" indent="0" algn="just">
-              <a:buNone/>
-            </a:pPr>
-            <a:r>
-              <a:rPr lang="en-US" sz="880" dirty="0">
-                <a:solidFill>
-                  <a:srgbClr val="CBD5E1"/>
-                </a:solidFill>
-                <a:latin typeface="Calibri" pitchFamily="34" charset="0"/>
-                <a:ea typeface="Calibri" pitchFamily="34" charset="-122"/>
-                <a:cs typeface="Calibri" pitchFamily="34" charset="-120"/>
-              </a:rPr>
-              <a:t>The student taps Export PDF. The PDF Service queries all entries, constructs the 9-slot landscape A4 grid, and produces the document. The student may save it to Downloads or share it instantly through the native OS share sheet.</a:t>
-            </a:r>
-            <a:endParaRPr lang="en-US" sz="880" dirty="0"/>
-          </a:p>
-        </p:txBody>
-      </p:sp>
-      <p:sp>
-        <p:nvSpPr>
-          <p:cNvPr id="30" name="Shape 28"/>
-          <p:cNvSpPr/>
-          <p:nvPr/>
-        </p:nvSpPr>
-        <p:spPr>
-          <a:xfrm>
-            <a:off x="4709160" y="3054096"/>
-            <a:ext cx="4251960" cy="877824"/>
-          </a:xfrm>
-          <a:prstGeom prst="rect">
-            <a:avLst/>
-          </a:prstGeom>
-          <a:solidFill>
-            <a:srgbClr val="0D2137"/>
-          </a:solidFill>
-          <a:ln w="12700">
-            <a:solidFill>
-              <a:srgbClr val="1E3A5F"/>
-            </a:solidFill>
-            <a:prstDash val="solid"/>
-          </a:ln>
-        </p:spPr>
-      </p:sp>
-      <p:sp>
-        <p:nvSpPr>
-          <p:cNvPr id="31" name="Shape 29"/>
-          <p:cNvSpPr/>
-          <p:nvPr/>
-        </p:nvSpPr>
-        <p:spPr>
-          <a:xfrm>
-            <a:off x="4800600" y="3236976"/>
-            <a:ext cx="457200" cy="457200"/>
-          </a:xfrm>
-          <a:prstGeom prst="line">
-            <a:avLst/>
-          </a:prstGeom>
-          <a:solidFill>
-            <a:srgbClr val="EC4899"/>
-          </a:solidFill>
-          <a:ln/>
-        </p:spPr>
-      </p:sp>
-      <p:sp>
-        <p:nvSpPr>
-          <p:cNvPr id="32" name="Text 30"/>
-          <p:cNvSpPr/>
-          <p:nvPr/>
-        </p:nvSpPr>
-        <p:spPr>
-          <a:xfrm>
-            <a:off x="4800600" y="3236976"/>
-            <a:ext cx="457200" cy="457200"/>
-          </a:xfrm>
-          <a:prstGeom prst="rect">
-            <a:avLst/>
-          </a:prstGeom>
-          <a:noFill/>
-          <a:ln/>
-        </p:spPr>
-        <p:txBody>
-          <a:bodyPr wrap="square" lIns="0" tIns="0" rIns="0" bIns="0" rtlCol="0" anchor="ctr"/>
-          <a:lstStyle/>
-          <a:p>
-            <a:pPr marL="0" indent="0" algn="ctr">
-              <a:buNone/>
-            </a:pPr>
-            <a:r>
-              <a:rPr lang="en-US" sz="1400" b="1" dirty="0">
-                <a:solidFill>
-                  <a:srgbClr val="0A1628"/>
-                </a:solidFill>
-                <a:latin typeface="Calibri" pitchFamily="34" charset="0"/>
-                <a:ea typeface="Calibri" pitchFamily="34" charset="-122"/>
-                <a:cs typeface="Calibri" pitchFamily="34" charset="-120"/>
-              </a:rPr>
-              <a:t>6</a:t>
-            </a:r>
-            <a:endParaRPr lang="en-US" sz="1400" dirty="0"/>
-          </a:p>
-        </p:txBody>
-      </p:sp>
-      <p:sp>
-        <p:nvSpPr>
-          <p:cNvPr id="33" name="Text 31"/>
-          <p:cNvSpPr/>
-          <p:nvPr/>
-        </p:nvSpPr>
-        <p:spPr>
-          <a:xfrm>
-            <a:off x="5349240" y="3108960"/>
-            <a:ext cx="3520440" cy="274320"/>
-          </a:xfrm>
-          <a:prstGeom prst="rect">
-            <a:avLst/>
-          </a:prstGeom>
-          <a:noFill/>
-          <a:ln/>
-        </p:spPr>
-        <p:txBody>
-          <a:bodyPr wrap="square" lIns="0" tIns="0" rIns="0" bIns="0" rtlCol="0" anchor="ctr"/>
-          <a:lstStyle/>
-          <a:p>
-            <a:pPr marL="0" indent="0">
-              <a:buNone/>
-            </a:pPr>
-            <a:r>
-              <a:rPr lang="en-US" sz="1050" b="1" dirty="0">
-                <a:solidFill>
-                  <a:srgbClr val="EC4899"/>
-                </a:solidFill>
-                <a:latin typeface="Calibri" pitchFamily="34" charset="0"/>
-                <a:ea typeface="Calibri" pitchFamily="34" charset="-122"/>
-                <a:cs typeface="Calibri" pitchFamily="34" charset="-120"/>
-              </a:rPr>
-              <a:t>Step 6 — Settings &amp; Configuration</a:t>
-            </a:r>
-            <a:endParaRPr lang="en-US" sz="1050" dirty="0"/>
-          </a:p>
-        </p:txBody>
-      </p:sp>
-      <p:sp>
-        <p:nvSpPr>
-          <p:cNvPr id="34" name="Text 32"/>
-          <p:cNvSpPr/>
-          <p:nvPr/>
-        </p:nvSpPr>
-        <p:spPr>
-          <a:xfrm>
-            <a:off x="5349240" y="3383280"/>
-            <a:ext cx="3520440" cy="512064"/>
-          </a:xfrm>
-          <a:prstGeom prst="rect">
-            <a:avLst/>
-          </a:prstGeom>
-          <a:noFill/>
-          <a:ln/>
-        </p:spPr>
-        <p:txBody>
-          <a:bodyPr wrap="square" lIns="12700" tIns="38100" rIns="38100" bIns="12700" rtlCol="0" anchor="ctr"/>
-          <a:lstStyle/>
-          <a:p>
-            <a:pPr marL="0" indent="0" algn="just">
-              <a:buNone/>
-            </a:pPr>
-            <a:r>
-              <a:rPr lang="en-US" sz="880" dirty="0">
-                <a:solidFill>
-                  <a:srgbClr val="CBD5E1"/>
-                </a:solidFill>
-                <a:latin typeface="Calibri" pitchFamily="34" charset="0"/>
-                <a:ea typeface="Calibri" pitchFamily="34" charset="-122"/>
-                <a:cs typeface="Calibri" pitchFamily="34" charset="-120"/>
-              </a:rPr>
-              <a:t>The Settings screen provides control over dark mode, active working days, Warning and Danger attendance thresholds, the subject master list, and declared holidays — allowing the app to adapt fully to each student's institutional context.</a:t>
-            </a:r>
-            <a:endParaRPr lang="en-US" sz="880" dirty="0"/>
-          </a:p>
-        </p:txBody>
-      </p:sp>
-      <p:sp>
-        <p:nvSpPr>
-          <p:cNvPr id="35" name="Shape 33"/>
-          <p:cNvSpPr/>
-          <p:nvPr/>
-        </p:nvSpPr>
-        <p:spPr>
-          <a:xfrm>
-            <a:off x="4709160" y="4059936"/>
-            <a:ext cx="4251960" cy="877824"/>
-          </a:xfrm>
-          <a:prstGeom prst="rect">
-            <a:avLst/>
-          </a:prstGeom>
-          <a:solidFill>
-            <a:srgbClr val="0D2137"/>
-          </a:solidFill>
-          <a:ln w="12700">
-            <a:solidFill>
-              <a:srgbClr val="1E3A5F"/>
-            </a:solidFill>
-            <a:prstDash val="solid"/>
-          </a:ln>
-        </p:spPr>
-      </p:sp>
-      <p:sp>
-        <p:nvSpPr>
-          <p:cNvPr id="36" name="Shape 34"/>
-          <p:cNvSpPr/>
-          <p:nvPr/>
-        </p:nvSpPr>
-        <p:spPr>
-          <a:xfrm>
-            <a:off x="4800600" y="4242816"/>
-            <a:ext cx="457200" cy="457200"/>
-          </a:xfrm>
-          <a:prstGeom prst="line">
-            <a:avLst/>
-          </a:prstGeom>
-          <a:solidFill>
-            <a:srgbClr val="06B6D4"/>
-          </a:solidFill>
-          <a:ln/>
-        </p:spPr>
-      </p:sp>
-      <p:sp>
-        <p:nvSpPr>
-          <p:cNvPr id="37" name="Text 35"/>
-          <p:cNvSpPr/>
-          <p:nvPr/>
-        </p:nvSpPr>
-        <p:spPr>
-          <a:xfrm>
-            <a:off x="4800600" y="4242816"/>
-            <a:ext cx="457200" cy="457200"/>
-          </a:xfrm>
-          <a:prstGeom prst="rect">
-            <a:avLst/>
-          </a:prstGeom>
-          <a:noFill/>
-          <a:ln/>
-        </p:spPr>
-        <p:txBody>
-          <a:bodyPr wrap="square" lIns="0" tIns="0" rIns="0" bIns="0" rtlCol="0" anchor="ctr"/>
-          <a:lstStyle/>
-          <a:p>
-            <a:pPr marL="0" indent="0" algn="ctr">
-              <a:buNone/>
-            </a:pPr>
-            <a:r>
-              <a:rPr lang="en-US" sz="1400" b="1" dirty="0">
-                <a:solidFill>
-                  <a:srgbClr val="0A1628"/>
-                </a:solidFill>
-                <a:latin typeface="Calibri" pitchFamily="34" charset="0"/>
-                <a:ea typeface="Calibri" pitchFamily="34" charset="-122"/>
-                <a:cs typeface="Calibri" pitchFamily="34" charset="-120"/>
-              </a:rPr>
-              <a:t>7</a:t>
-            </a:r>
-            <a:endParaRPr lang="en-US" sz="1400" dirty="0"/>
-          </a:p>
-        </p:txBody>
-      </p:sp>
-      <p:sp>
-        <p:nvSpPr>
-          <p:cNvPr id="38" name="Text 36"/>
-          <p:cNvSpPr/>
-          <p:nvPr/>
-        </p:nvSpPr>
-        <p:spPr>
-          <a:xfrm>
-            <a:off x="5349240" y="4114800"/>
-            <a:ext cx="3520440" cy="274320"/>
-          </a:xfrm>
-          <a:prstGeom prst="rect">
-            <a:avLst/>
-          </a:prstGeom>
-          <a:noFill/>
-          <a:ln/>
-        </p:spPr>
-        <p:txBody>
-          <a:bodyPr wrap="square" lIns="0" tIns="0" rIns="0" bIns="0" rtlCol="0" anchor="ctr"/>
-          <a:lstStyle/>
-          <a:p>
-            <a:pPr marL="0" indent="0">
-              <a:buNone/>
-            </a:pPr>
-            <a:r>
-              <a:rPr lang="en-US" sz="1050" b="1" dirty="0">
-                <a:solidFill>
-                  <a:srgbClr val="06B6D4"/>
-                </a:solidFill>
-                <a:latin typeface="Calibri" pitchFamily="34" charset="0"/>
-                <a:ea typeface="Calibri" pitchFamily="34" charset="-122"/>
-                <a:cs typeface="Calibri" pitchFamily="34" charset="-120"/>
-              </a:rPr>
-              <a:t>Step 7 — 45-Day Semester Reset Prompt</a:t>
-            </a:r>
-            <a:endParaRPr lang="en-US" sz="1050" dirty="0"/>
-          </a:p>
-        </p:txBody>
-      </p:sp>
-      <p:sp>
-        <p:nvSpPr>
-          <p:cNvPr id="39" name="Text 37"/>
-          <p:cNvSpPr/>
-          <p:nvPr/>
-        </p:nvSpPr>
-        <p:spPr>
-          <a:xfrm>
-            <a:off x="5349240" y="4389120"/>
-            <a:ext cx="3520440" cy="512064"/>
-          </a:xfrm>
-          <a:prstGeom prst="rect">
-            <a:avLst/>
-          </a:prstGeom>
-          <a:noFill/>
-          <a:ln/>
-        </p:spPr>
-        <p:txBody>
-          <a:bodyPr wrap="square" lIns="12700" tIns="38100" rIns="38100" bIns="12700" rtlCol="0" anchor="ctr"/>
-          <a:lstStyle/>
-          <a:p>
-            <a:pPr marL="0" indent="0" algn="just">
-              <a:buNone/>
-            </a:pPr>
-            <a:r>
-              <a:rPr lang="en-US" sz="880" dirty="0">
-                <a:solidFill>
-                  <a:srgbClr val="CBD5E1"/>
-                </a:solidFill>
-                <a:latin typeface="Calibri" pitchFamily="34" charset="0"/>
-                <a:ea typeface="Calibri" pitchFamily="34" charset="-122"/>
-                <a:cs typeface="Calibri" pitchFamily="34" charset="-120"/>
-              </a:rPr>
-              <a:t>After 45 days of use, the next app launch triggers a dialog: A new semester may have started — Clear all data? The student may reset everything for the new semester, defer the prompt by 7 days, or dismiss it entirely without any data loss.</a:t>
-            </a:r>
-            <a:endParaRPr lang="en-US" sz="880" dirty="0"/>
-          </a:p>
-        </p:txBody>
-      </p:sp>
-      <p:sp>
-        <p:nvSpPr>
-          <p:cNvPr id="40" name="Text 38"/>
-          <p:cNvSpPr/>
-          <p:nvPr/>
-        </p:nvSpPr>
-        <p:spPr>
-          <a:xfrm>
-            <a:off x="228600" y="4919472"/>
-            <a:ext cx="8686800" cy="182880"/>
-          </a:xfrm>
-          <a:prstGeom prst="rect">
-            <a:avLst/>
-          </a:prstGeom>
-          <a:noFill/>
-          <a:ln/>
-        </p:spPr>
-        <p:txBody>
-          <a:bodyPr wrap="square" lIns="0" tIns="0" rIns="0" bIns="0" rtlCol="0" anchor="ctr"/>
-          <a:lstStyle/>
-          <a:p>
-            <a:pPr marL="0" indent="0" algn="ctr">
-              <a:buNone/>
-            </a:pPr>
-            <a:r>
-              <a:rPr lang="en-US" sz="850" i="1" dirty="0">
-                <a:solidFill>
-                  <a:srgbClr val="3D5A80"/>
-                </a:solidFill>
-                <a:latin typeface="Calibri" pitchFamily="34" charset="0"/>
-                <a:ea typeface="Calibri" pitchFamily="34" charset="-122"/>
-                <a:cs typeface="Calibri" pitchFamily="34" charset="-120"/>
-              </a:rPr>
-              <a:t>SchedIQ — Production-ready · Offline-First · Intelligent Academic Scheduling</a:t>
-            </a:r>
-            <a:endParaRPr lang="en-US" sz="850" dirty="0"/>
-          </a:p>
-        </p:txBody>
-      </p:sp>
-      <p:pic>
-        <p:nvPicPr>
-          <p:cNvPr id="41" name="Picture 40"/>
-          <p:cNvPicPr>
-            <a:picLocks noChangeAspect="1"/>
-          </p:cNvPicPr>
-          <p:nvPr/>
-        </p:nvPicPr>
-        <p:blipFill>
-          <a:blip r:embed="rId3">
-            <a:extLst>
-              <a:ext uri="{28A0092B-C50C-407E-A947-70E740481C1C}">
-                <a14:useLocalDpi xmlns:a14="http://schemas.microsoft.com/office/drawing/2010/main" val="0"/>
-              </a:ext>
-            </a:extLst>
-          </a:blip>
-          <a:stretch>
-            <a:fillRect/>
-          </a:stretch>
-        </p:blipFill>
-        <p:spPr>
-          <a:xfrm>
-            <a:off x="1551689" y="0"/>
-            <a:ext cx="6040622" cy="5143500"/>
-          </a:xfrm>
-          <a:prstGeom prst="rect">
-            <a:avLst/>
-          </a:prstGeom>
-        </p:spPr>
-      </p:pic>
-    </p:spTree>
-    <p:extLst>
-      <p:ext uri="{BB962C8B-B14F-4D97-AF65-F5344CB8AC3E}">
-        <p14:creationId xmlns:p14="http://schemas.microsoft.com/office/powerpoint/2010/main" val="213431554"/>
-      </p:ext>
-    </p:extLst>
   </p:cSld>
   <p:clrMapOvr>
     <a:masterClrMapping/>
@@ -14749,7 +13855,7 @@
               <a:buNone/>
             </a:pPr>
             <a:r>
-              <a:rPr lang="en-US" sz="2200" b="1" dirty="0">
+              <a:rPr lang="en-US" sz="2200" b="1" dirty="0" smtClean="0">
                 <a:solidFill>
                   <a:srgbClr val="FFFFFF"/>
                 </a:solidFill>
@@ -14757,7 +13863,7 @@
                 <a:ea typeface="Calibri" pitchFamily="34" charset="-122"/>
                 <a:cs typeface="Calibri" pitchFamily="34" charset="-120"/>
               </a:rPr>
-              <a:t>Novelty of the Project</a:t>
+              <a:t>Architecture Diagram of the Project</a:t>
             </a:r>
             <a:endParaRPr lang="en-US" sz="2200" dirty="0"/>
           </a:p>
@@ -14788,7 +13894,7 @@
               <a:buNone/>
             </a:pPr>
             <a:r>
-              <a:rPr lang="en-US" sz="1150" i="1" dirty="0">
+              <a:rPr lang="en-US" sz="1150" i="1" dirty="0" err="1" smtClean="0">
                 <a:solidFill>
                   <a:srgbClr val="475569"/>
                 </a:solidFill>
@@ -14796,9 +13902,31 @@
                 <a:ea typeface="Calibri" pitchFamily="34" charset="-122"/>
                 <a:cs typeface="Calibri" pitchFamily="34" charset="-120"/>
               </a:rPr>
-              <a:t>SchedIQ introduces seven original contributions that distinguish it from any existing academic scheduling tool.</a:t>
-            </a:r>
-            <a:endParaRPr lang="en-US" sz="1150" dirty="0"/>
+              <a:t>SchedIQ</a:t>
+            </a:r>
+            <a:r>
+              <a:rPr lang="en-US" sz="1150" i="1" dirty="0" smtClean="0">
+                <a:solidFill>
+                  <a:srgbClr val="475569"/>
+                </a:solidFill>
+                <a:latin typeface="Calibri" pitchFamily="34" charset="0"/>
+                <a:ea typeface="Calibri" pitchFamily="34" charset="-122"/>
+                <a:cs typeface="Calibri" pitchFamily="34" charset="-120"/>
+              </a:rPr>
+              <a:t> architecture diagram</a:t>
+            </a:r>
+            <a:r>
+              <a:rPr lang="en-US" sz="1150" dirty="0"/>
+              <a:t>:</a:t>
+            </a:r>
+            <a:endParaRPr lang="en-US" sz="1150" i="1" dirty="0" smtClean="0">
+              <a:solidFill>
+                <a:srgbClr val="475569"/>
+              </a:solidFill>
+              <a:latin typeface="Calibri" pitchFamily="34" charset="0"/>
+              <a:ea typeface="Calibri" pitchFamily="34" charset="-122"/>
+              <a:cs typeface="Calibri" pitchFamily="34" charset="-120"/>
+            </a:endParaRPr>
           </a:p>
         </p:txBody>
       </p:sp>

</xml_diff>